<commit_message>
Replace Latha (ET-only) with Gupta 2017 (wheat yield) on India slide
Latha et al., 2018 studies evapotranspiration, not productivity.
Replaced with Gupta et al., 2017 which directly quantifies wheat
yield loss from aerosol (1 SD less AOD -> +4.8% yield, India 1981-2009).

Co-Authored-By: Claude Opus 4.6 <noreply@anthropic.com>
Claude-Session: https://claude.ai/code/session_013ce4PKS59x4i27j5CRjVKQ
</commit_message>
<xml_diff>
--- a/seminar/Evidence_India_South_Asia.pptx
+++ b/seminar/Evidence_India_South_Asia.pptx
@@ -107,7 +107,7 @@
   <p:extLst>
     <p:ext uri="{521415D9-36F7-43E2-AB2F-B90AF26B5E84}">
       <p14:sectionLst xmlns:p14="http://schemas.microsoft.com/office/powerpoint/2010/main">
-        <p14:section name="7 · Evidence" id="{790cef53-5f6c-ab93-8504-cc5bd4917b04}">
+        <p14:section name="7 · Evidence" id="{8fc93fac-8273-a0af-79b7-9a7378484c32}">
           <p14:sldIdLst>
             <p14:sldId id="256"/>
           </p14:sldIdLst>
@@ -521,7 +521,7 @@
 Burney and Ramanathan, 2014, used district-level data across all of India for wheat from 1980 to 2010. They found that the combined direct effects of black carbon and tropospheric ozone, beyond their indirect climate effects, reduced wheat yields by up to 36 percent, making air pollution a major threat to Indian food security.
 Gupta and colleagues, 2024, analysed cropland areas across India from 1998 to 2019 using satellite-derived aerosol optical depth and found that aerosol pollution reduced rice yield by 7.9 percent and maize yield by 8.8 percent.
 Gupta and colleagues, 2025, examined rice yields across nine agroclimatic zones of India. The all-India average decline due to aerosol was 0.73 percent per year, but the Eastern Plateau and Hills, labelled EPH on the map, suffered the most at 4.88 percent per year. The map on the right shows the spatial pattern of this AOD-related yield change.
-Latha and colleagues, 2018, studied a tea plantation area in Dibrugarh, Assam, from 2008 to 2009. They found a correlation of 0.83 between AOD and evapotranspiration, with ET falling as AOD rises, because aerosol reduces net surface radiation through aerosol radiative forcing.
+Gupta and colleagues, 2017, analysed the impact of temperature, solar radiation and aerosols on wheat yields across India from 1981 to 2009. They found that a decrease in aerosol optical depth equivalent to one standard deviation would raise wheat yields by 4.8 percent, showing a clear negative impact of aerosol loading on wheat productivity.
 Jannat and colleagues, 2026, studied boro rice across the eight administrative divisions of Bangladesh from 2007 to 2023. The aerosol effect was positive, meaning higher AOD raised yield, in five divisions: Khulna, Barisal, Rangpur, Mymensingh and Sylhet, and negative in three: Chattogram, Dhaka and Rajshahi.
 The bottom strip summarises the overall pattern: India's aerosol is high, rising and partly absorbing, which mostly lowers yields through less sunlight reaching the crop, weakened monsoon rainfall and warmer nights. Gains appear only where AOD is moderate.</a:t>
             </a:r>
@@ -2503,7 +2503,7 @@
                             <a:schemeClr val="tx2"/>
                           </a:solidFill>
                         </a:rPr>
-                        <a:t>Dibrugarh, Assam</a:t>
+                        <a:t>India</a:t>
                       </a:r>
                       <a:endParaRPr lang="en-US" sz="1400" dirty="0"/>
                     </a:p>
@@ -2564,7 +2564,7 @@
                             <a:schemeClr val="tx1"/>
                           </a:solidFill>
                         </a:rPr>
-                        <a:t>Tea plantation · 2008–09</a:t>
+                        <a:t>Wheat · 1981–2009</a:t>
                       </a:r>
                       <a:endParaRPr lang="en-US" sz="1400" dirty="0"/>
                     </a:p>
@@ -2625,7 +2625,7 @@
                             <a:schemeClr val="tx1"/>
                           </a:solidFill>
                         </a:rPr>
-                        <a:t>ET falls as AOD rises; r = 0.83</a:t>
+                        <a:t>1 SD less AOD → +4.8% yield</a:t>
                       </a:r>
                       <a:endParaRPr lang="en-US" sz="1400" dirty="0"/>
                     </a:p>
@@ -2686,7 +2686,7 @@
                             <a:schemeClr val="accent1"/>
                           </a:solidFill>
                         </a:rPr>
-                        <a:t>Latha et al., 2018</a:t>
+                        <a:t>Gupta et al., 2017</a:t>
                       </a:r>
                       <a:endParaRPr lang="en-US" sz="1400" dirty="0"/>
                     </a:p>

</xml_diff>